<commit_message>
Fixed connection in drawing
</commit_message>
<xml_diff>
--- a/Planning/E-R Diagram.pptx
+++ b/Planning/E-R Diagram.pptx
@@ -104,6 +104,11 @@
       </a:defRPr>
     </a:lvl9pPr>
   </p:defaultTextStyle>
+  <p:extLst>
+    <p:ext uri="{EFAFB233-063F-42B5-8137-9DF3F51BA10A}">
+      <p15:sldGuideLst xmlns:p15="http://schemas.microsoft.com/office/powerpoint/2012/main"/>
+    </p:ext>
+  </p:extLst>
 </p:presentation>
 </file>
 
@@ -13323,7 +13328,7 @@
         <p:spPr>
           <a:xfrm>
             <a:off x="10326874" y="765024"/>
-            <a:ext cx="0" cy="2509898"/>
+            <a:ext cx="10314" cy="2799523"/>
           </a:xfrm>
           <a:prstGeom prst="line">
             <a:avLst/>
@@ -14133,7 +14138,7 @@
         </p:nvSpPr>
         <p:spPr>
           <a:xfrm>
-            <a:off x="10282854" y="3374579"/>
+            <a:off x="10326873" y="3392390"/>
             <a:ext cx="226828" cy="215444"/>
           </a:xfrm>
           <a:prstGeom prst="rect">

</xml_diff>